<commit_message>
Update final presentation architecture
</commit_message>
<xml_diff>
--- a/docs/final/soil_moisture_gateway_presentation.pptx
+++ b/docs/final/soil_moisture_gateway_presentation.pptx
@@ -4298,30 +4298,6 @@
           </a:p>
         </p:txBody>
       </p:sp>
-      <p:pic>
-        <p:nvPicPr>
-          <p:cNvPr id="3" name="Picture 2" descr="architecture.png"/>
-          <p:cNvPicPr>
-            <a:picLocks noChangeAspect="1"/>
-          </p:cNvPicPr>
-          <p:nvPr/>
-        </p:nvPicPr>
-        <p:blipFill>
-          <a:blip r:embed="rId2"/>
-          <a:stretch>
-            <a:fillRect/>
-          </a:stretch>
-        </p:blipFill>
-        <p:spPr>
-          <a:xfrm>
-            <a:off x="914400" y="1234440"/>
-            <a:ext cx="10332720" cy="438196"/>
-          </a:xfrm>
-          <a:prstGeom prst="rect">
-            <a:avLst/>
-          </a:prstGeom>
-        </p:spPr>
-      </p:pic>
       <p:sp>
         <p:nvSpPr>
           <p:cNvPr id="4" name="TextBox 3"/>
@@ -4357,6 +4333,30 @@
           </a:p>
         </p:txBody>
       </p:sp>
+      <p:pic>
+        <p:nvPicPr>
+          <p:cNvPr id="5" name="Picture 4" descr="architecture.png"/>
+          <p:cNvPicPr>
+            <a:picLocks noChangeAspect="1"/>
+          </p:cNvPicPr>
+          <p:nvPr/>
+        </p:nvPicPr>
+        <p:blipFill>
+          <a:blip r:embed="rId3"/>
+          <a:stretch>
+            <a:fillRect/>
+          </a:stretch>
+        </p:blipFill>
+        <p:spPr>
+          <a:xfrm>
+            <a:off x="2148840" y="1234440"/>
+            <a:ext cx="2537631" cy="4754880"/>
+          </a:xfrm>
+          <a:prstGeom prst="rect">
+            <a:avLst/>
+          </a:prstGeom>
+        </p:spPr>
+      </p:pic>
     </p:spTree>
   </p:cSld>
   <p:clrMapOvr>

</xml_diff>

<commit_message>
Update final report and presentation
</commit_message>
<xml_diff>
--- a/docs/final/soil_moisture_gateway_presentation.pptx
+++ b/docs/final/soil_moisture_gateway_presentation.pptx
@@ -3371,7 +3371,7 @@
               </a:defRPr>
             </a:pPr>
             <a:r>
-              <a:t>Flask backend startup — PASS</a:t>
+              <a:t>C++ HTTP backend startup — PASS</a:t>
             </a:r>
           </a:p>
           <a:p>
@@ -4175,7 +4175,7 @@
               </a:defRPr>
             </a:pPr>
             <a:r>
-              <a:t>Build a Flask REST backend with SQLite storage.</a:t>
+              <a:t>Build a C++ HTTP backend REST backend with SQLite storage.</a:t>
             </a:r>
           </a:p>
           <a:p>
@@ -4488,7 +4488,7 @@
               </a:defRPr>
             </a:pPr>
             <a:r>
-              <a:t>Python Flask for REST backend</a:t>
+              <a:t>C++ C++ HTTP backend for REST backend</a:t>
             </a:r>
           </a:p>
           <a:p>
@@ -5068,7 +5068,7 @@
               </a:defRPr>
             </a:pPr>
             <a:r>
-              <a:t>Flask Backend &amp; Database</a:t>
+              <a:t>C++ HTTP backend Backend &amp; Database</a:t>
             </a:r>
           </a:p>
         </p:txBody>
@@ -5106,7 +5106,7 @@
               </a:defRPr>
             </a:pPr>
             <a:r>
-              <a:t>Flask provides REST API endpoints for sensor information.</a:t>
+              <a:t>C++ HTTP backend provides REST API endpoints for sensor information.</a:t>
             </a:r>
           </a:p>
           <a:p>
@@ -5307,7 +5307,7 @@
               </a:defRPr>
             </a:pPr>
             <a:r>
-              <a:t>Dashboard communicates with the Flask backend.</a:t>
+              <a:t>Dashboard communicates with the C++ HTTP backend.</a:t>
             </a:r>
           </a:p>
           <a:p>

</xml_diff>